<commit_message>
imagens novas, atualização no banner
</commit_message>
<xml_diff>
--- a/Documentos/Banner_FECAP_CCOMP5_RivoTrio.pptx
+++ b/Documentos/Banner_FECAP_CCOMP5_RivoTrio.pptx
@@ -266,7 +266,7 @@
       </p15:sldGuideLst>
     </p:ext>
     <p:ext uri="GoogleSlidesCustomDataVersion2">
-      <go:slidesCustomData xmlns:go="http://customooxmlschemas.google.com/" xmlns:ahyp="http://schemas.microsoft.com/office/drawing/2018/hyperlinkcolor" xmlns:p15="http://schemas.microsoft.com/office/powerpoint/2012/main" xmlns:p14="http://schemas.microsoft.com/office/powerpoint/2010/main" xmlns:com="http://schemas.openxmlformats.org/drawingml/2006/compatibility" xmlns:pvml="urn:schemas-microsoft-com:office:powerpoint" xmlns:v="urn:schemas-microsoft-com:vml" xmlns:o="urn:schemas-microsoft-com:office:office" xmlns:dgm="http://schemas.openxmlformats.org/drawingml/2006/diagram" xmlns:c="http://schemas.openxmlformats.org/drawingml/2006/chart" xmlns:mv="urn:schemas-microsoft-com:mac:vml" xmlns:mc="http://schemas.openxmlformats.org/markup-compatibility/2006" xmlns="" r:id="rId12" roundtripDataSignature="AMtx7miHexfJ4GjhJ20xDvwvs2ulWXUQ1A=="/>
+      <go:slidesCustomData xmlns="" xmlns:mc="http://schemas.openxmlformats.org/markup-compatibility/2006" xmlns:mv="urn:schemas-microsoft-com:mac:vml" xmlns:c="http://schemas.openxmlformats.org/drawingml/2006/chart" xmlns:dgm="http://schemas.openxmlformats.org/drawingml/2006/diagram" xmlns:o="urn:schemas-microsoft-com:office:office" xmlns:v="urn:schemas-microsoft-com:vml" xmlns:pvml="urn:schemas-microsoft-com:office:powerpoint" xmlns:com="http://schemas.openxmlformats.org/drawingml/2006/compatibility" xmlns:p14="http://schemas.microsoft.com/office/powerpoint/2010/main" xmlns:p15="http://schemas.microsoft.com/office/powerpoint/2012/main" xmlns:ahyp="http://schemas.microsoft.com/office/drawing/2018/hyperlinkcolor" xmlns:go="http://customooxmlschemas.google.com/" r:id="rId12" roundtripDataSignature="AMtx7miHexfJ4GjhJ20xDvwvs2ulWXUQ1A=="/>
     </p:ext>
   </p:extLst>
 </p:presentation>
@@ -19107,10 +19107,10 @@
       </p:pic>
       <p:pic>
         <p:nvPicPr>
-          <p:cNvPr id="7" name="Imagem 6">
+          <p:cNvPr id="4" name="Imagem 3">
             <a:extLst>
               <a:ext uri="{FF2B5EF4-FFF2-40B4-BE49-F238E27FC236}">
-                <a16:creationId xmlns:a16="http://schemas.microsoft.com/office/drawing/2014/main" id="{7B65A6CB-3FED-E158-97DE-34F1B6FA62C9}"/>
+                <a16:creationId xmlns:a16="http://schemas.microsoft.com/office/drawing/2014/main" id="{D750FC00-4410-F127-0412-1D4C89BF0E3E}"/>
               </a:ext>
             </a:extLst>
           </p:cNvPr>
@@ -19127,38 +19127,8 @@
         </p:blipFill>
         <p:spPr>
           <a:xfrm>
-            <a:off x="16248238" y="18941658"/>
-            <a:ext cx="9935962" cy="2810267"/>
-          </a:xfrm>
-          <a:prstGeom prst="rect">
-            <a:avLst/>
-          </a:prstGeom>
-        </p:spPr>
-      </p:pic>
-      <p:pic>
-        <p:nvPicPr>
-          <p:cNvPr id="9" name="Imagem 8">
-            <a:extLst>
-              <a:ext uri="{FF2B5EF4-FFF2-40B4-BE49-F238E27FC236}">
-                <a16:creationId xmlns:a16="http://schemas.microsoft.com/office/drawing/2014/main" id="{2451746D-C164-8E41-DA64-FBEEE2DF7CD1}"/>
-              </a:ext>
-            </a:extLst>
-          </p:cNvPr>
-          <p:cNvPicPr>
-            <a:picLocks noChangeAspect="1"/>
-          </p:cNvPicPr>
-          <p:nvPr/>
-        </p:nvPicPr>
-        <p:blipFill>
-          <a:blip r:embed="rId15"/>
-          <a:stretch>
-            <a:fillRect/>
-          </a:stretch>
-        </p:blipFill>
-        <p:spPr>
-          <a:xfrm>
-            <a:off x="16248237" y="15779591"/>
-            <a:ext cx="7791633" cy="3233475"/>
+            <a:off x="15656201" y="16307447"/>
+            <a:ext cx="11769276" cy="5450646"/>
           </a:xfrm>
           <a:prstGeom prst="rect">
             <a:avLst/>

</xml_diff>